<commit_message>
Fix slide 5 layout — eliminate all overlapping elements
Recalculated all y-coordinates with explicit zones and gaps:
cards (1.78–4.38), script block (4.52–5.62), warning (5.76–6.50).
Moved step number to a small badge inside the card, added an inner
divider line, and gave body text a clean 1.3" allocation below the title.

https://claude.ai/code/session_01KgcXbPuanhjLEtgnHxCXas
</commit_message>
<xml_diff>
--- a/VelaSync_Sales_Process.pptx
+++ b/VelaSync_Sales_Process.pptx
@@ -17974,8 +17974,8 @@
         </p:nvSpPr>
         <p:spPr>
           <a:xfrm>
-            <a:off x="411480" y="1664208"/>
-            <a:ext cx="2670048" cy="2514600"/>
+            <a:off x="411480" y="1627632"/>
+            <a:ext cx="2724912" cy="2377440"/>
           </a:xfrm>
           <a:prstGeom prst="rect">
             <a:avLst/>
@@ -18019,8 +18019,8 @@
         </p:nvSpPr>
         <p:spPr>
           <a:xfrm>
-            <a:off x="411480" y="1664208"/>
-            <a:ext cx="2670048" cy="36576"/>
+            <a:off x="411480" y="1627632"/>
+            <a:ext cx="2724912" cy="36576"/>
           </a:xfrm>
           <a:prstGeom prst="rect">
             <a:avLst/>
@@ -18056,14 +18056,91 @@
       </p:sp>
       <p:sp>
         <p:nvSpPr>
-          <p:cNvPr id="11" name="TextBox 10"/>
-          <p:cNvSpPr txBox="1"/>
-          <p:nvPr/>
-        </p:nvSpPr>
-        <p:spPr>
-          <a:xfrm>
-            <a:off x="594360" y="1828800"/>
-            <a:ext cx="530352" cy="502920"/>
+          <p:cNvPr id="11" name="Rectangle 10"/>
+          <p:cNvSpPr/>
+          <p:nvPr/>
+        </p:nvSpPr>
+        <p:spPr>
+          <a:xfrm>
+            <a:off x="2660904" y="1719072"/>
+            <a:ext cx="347472" cy="256032"/>
+          </a:xfrm>
+          <a:prstGeom prst="rect">
+            <a:avLst/>
+          </a:prstGeom>
+          <a:solidFill>
+            <a:srgbClr val="1C2E2E"/>
+          </a:solidFill>
+          <a:ln>
+            <a:noFill/>
+          </a:ln>
+        </p:spPr>
+        <p:style>
+          <a:lnRef idx="1">
+            <a:schemeClr val="accent1"/>
+          </a:lnRef>
+          <a:fillRef idx="3">
+            <a:schemeClr val="accent1"/>
+          </a:fillRef>
+          <a:effectRef idx="2">
+            <a:schemeClr val="accent1"/>
+          </a:effectRef>
+          <a:fontRef idx="minor">
+            <a:schemeClr val="lt1"/>
+          </a:fontRef>
+        </p:style>
+        <p:txBody>
+          <a:bodyPr rtlCol="0" anchor="ctr"/>
+          <a:lstStyle/>
+          <a:p>
+            <a:pPr algn="ctr"/>
+          </a:p>
+        </p:txBody>
+      </p:sp>
+      <p:sp>
+        <p:nvSpPr>
+          <p:cNvPr id="12" name="TextBox 11"/>
+          <p:cNvSpPr txBox="1"/>
+          <p:nvPr/>
+        </p:nvSpPr>
+        <p:spPr>
+          <a:xfrm>
+            <a:off x="2660904" y="1719072"/>
+            <a:ext cx="347472" cy="256032"/>
+          </a:xfrm>
+          <a:prstGeom prst="rect">
+            <a:avLst/>
+          </a:prstGeom>
+          <a:noFill/>
+        </p:spPr>
+        <p:txBody>
+          <a:bodyPr wrap="square">
+            <a:spAutoFit/>
+          </a:bodyPr>
+          <a:lstStyle/>
+          <a:p>
+            <a:pPr algn="ctr"/>
+            <a:r>
+              <a:rPr sz="800" b="1" i="0">
+                <a:solidFill>
+                  <a:srgbClr val="3AAEAE"/>
+                </a:solidFill>
+              </a:rPr>
+              <a:t>01</a:t>
+            </a:r>
+          </a:p>
+        </p:txBody>
+      </p:sp>
+      <p:sp>
+        <p:nvSpPr>
+          <p:cNvPr id="13" name="TextBox 12"/>
+          <p:cNvSpPr txBox="1"/>
+          <p:nvPr/>
+        </p:nvSpPr>
+        <p:spPr>
+          <a:xfrm>
+            <a:off x="548640" y="1719072"/>
+            <a:ext cx="502920" cy="475488"/>
           </a:xfrm>
           <a:prstGeom prst="rect">
             <a:avLst/>
@@ -18090,102 +18167,34 @@
       </p:sp>
       <p:sp>
         <p:nvSpPr>
-          <p:cNvPr id="12" name="TextBox 11"/>
-          <p:cNvSpPr txBox="1"/>
-          <p:nvPr/>
-        </p:nvSpPr>
-        <p:spPr>
-          <a:xfrm>
-            <a:off x="2441448" y="1847088"/>
-            <a:ext cx="502920" cy="347472"/>
-          </a:xfrm>
-          <a:prstGeom prst="rect">
-            <a:avLst/>
-          </a:prstGeom>
-          <a:noFill/>
-        </p:spPr>
-        <p:txBody>
-          <a:bodyPr wrap="square">
-            <a:spAutoFit/>
-          </a:bodyPr>
-          <a:lstStyle/>
-          <a:p>
-            <a:pPr algn="r"/>
-            <a:r>
-              <a:rPr sz="1800" b="1" i="0">
-                <a:solidFill>
-                  <a:srgbClr val="2B8E8E"/>
-                </a:solidFill>
-              </a:rPr>
-              <a:t>01</a:t>
-            </a:r>
-          </a:p>
-        </p:txBody>
-      </p:sp>
-      <p:sp>
-        <p:nvSpPr>
-          <p:cNvPr id="13" name="TextBox 12"/>
-          <p:cNvSpPr txBox="1"/>
-          <p:nvPr/>
-        </p:nvSpPr>
-        <p:spPr>
-          <a:xfrm>
-            <a:off x="594360" y="2359152"/>
-            <a:ext cx="2304288" cy="347472"/>
-          </a:xfrm>
-          <a:prstGeom prst="rect">
-            <a:avLst/>
-          </a:prstGeom>
-          <a:noFill/>
-        </p:spPr>
-        <p:txBody>
-          <a:bodyPr wrap="square">
-            <a:spAutoFit/>
-          </a:bodyPr>
-          <a:lstStyle/>
-          <a:p>
-            <a:pPr algn="l"/>
-            <a:r>
-              <a:rPr sz="1200" b="1" i="0">
+          <p:cNvPr id="14" name="TextBox 13"/>
+          <p:cNvSpPr txBox="1"/>
+          <p:nvPr/>
+        </p:nvSpPr>
+        <p:spPr>
+          <a:xfrm>
+            <a:off x="548640" y="2267712"/>
+            <a:ext cx="2450592" cy="329184"/>
+          </a:xfrm>
+          <a:prstGeom prst="rect">
+            <a:avLst/>
+          </a:prstGeom>
+          <a:noFill/>
+        </p:spPr>
+        <p:txBody>
+          <a:bodyPr wrap="square">
+            <a:spAutoFit/>
+          </a:bodyPr>
+          <a:lstStyle/>
+          <a:p>
+            <a:pPr algn="l"/>
+            <a:r>
+              <a:rPr sz="1150" b="1" i="0">
                 <a:solidFill>
                   <a:srgbClr val="EEF7F7"/>
                 </a:solidFill>
               </a:rPr>
               <a:t>Google Them</a:t>
-            </a:r>
-          </a:p>
-        </p:txBody>
-      </p:sp>
-      <p:sp>
-        <p:nvSpPr>
-          <p:cNvPr id="14" name="TextBox 13"/>
-          <p:cNvSpPr txBox="1"/>
-          <p:nvPr/>
-        </p:nvSpPr>
-        <p:spPr>
-          <a:xfrm>
-            <a:off x="594360" y="2743200"/>
-            <a:ext cx="2304288" cy="1325880"/>
-          </a:xfrm>
-          <a:prstGeom prst="rect">
-            <a:avLst/>
-          </a:prstGeom>
-          <a:noFill/>
-        </p:spPr>
-        <p:txBody>
-          <a:bodyPr wrap="square">
-            <a:spAutoFit/>
-          </a:bodyPr>
-          <a:lstStyle/>
-          <a:p>
-            <a:pPr algn="l"/>
-            <a:r>
-              <a:rPr sz="900" b="0" i="0">
-                <a:solidFill>
-                  <a:srgbClr val="9ABFBF"/>
-                </a:solidFill>
-              </a:rPr>
-              <a:t>Search the business name. What comes up? Do they rank? Do they even appear?</a:t>
             </a:r>
           </a:p>
         </p:txBody>
@@ -18198,8 +18207,85 @@
         </p:nvSpPr>
         <p:spPr>
           <a:xfrm>
-            <a:off x="3319272" y="1664208"/>
-            <a:ext cx="2670048" cy="2514600"/>
+            <a:off x="548640" y="2633472"/>
+            <a:ext cx="2450592" cy="7315"/>
+          </a:xfrm>
+          <a:prstGeom prst="rect">
+            <a:avLst/>
+          </a:prstGeom>
+          <a:solidFill>
+            <a:srgbClr val="1C2E2E"/>
+          </a:solidFill>
+          <a:ln>
+            <a:noFill/>
+          </a:ln>
+        </p:spPr>
+        <p:style>
+          <a:lnRef idx="1">
+            <a:schemeClr val="accent1"/>
+          </a:lnRef>
+          <a:fillRef idx="3">
+            <a:schemeClr val="accent1"/>
+          </a:fillRef>
+          <a:effectRef idx="2">
+            <a:schemeClr val="accent1"/>
+          </a:effectRef>
+          <a:fontRef idx="minor">
+            <a:schemeClr val="lt1"/>
+          </a:fontRef>
+        </p:style>
+        <p:txBody>
+          <a:bodyPr rtlCol="0" anchor="ctr"/>
+          <a:lstStyle/>
+          <a:p>
+            <a:pPr algn="ctr"/>
+          </a:p>
+        </p:txBody>
+      </p:sp>
+      <p:sp>
+        <p:nvSpPr>
+          <p:cNvPr id="16" name="TextBox 15"/>
+          <p:cNvSpPr txBox="1"/>
+          <p:nvPr/>
+        </p:nvSpPr>
+        <p:spPr>
+          <a:xfrm>
+            <a:off x="548640" y="2724912"/>
+            <a:ext cx="2450592" cy="1188720"/>
+          </a:xfrm>
+          <a:prstGeom prst="rect">
+            <a:avLst/>
+          </a:prstGeom>
+          <a:noFill/>
+        </p:spPr>
+        <p:txBody>
+          <a:bodyPr wrap="square">
+            <a:spAutoFit/>
+          </a:bodyPr>
+          <a:lstStyle/>
+          <a:p>
+            <a:pPr algn="l"/>
+            <a:r>
+              <a:rPr sz="900" b="0" i="0">
+                <a:solidFill>
+                  <a:srgbClr val="9ABFBF"/>
+                </a:solidFill>
+              </a:rPr>
+              <a:t>Search the business. Do they appear at all? What comes up first — them or a competitor?</a:t>
+            </a:r>
+          </a:p>
+        </p:txBody>
+      </p:sp>
+      <p:sp>
+        <p:nvSpPr>
+          <p:cNvPr id="17" name="Rectangle 16"/>
+          <p:cNvSpPr/>
+          <p:nvPr/>
+        </p:nvSpPr>
+        <p:spPr>
+          <a:xfrm>
+            <a:off x="3246120" y="1627632"/>
+            <a:ext cx="2724912" cy="2377440"/>
           </a:xfrm>
           <a:prstGeom prst="rect">
             <a:avLst/>
@@ -18237,14 +18323,14 @@
       </p:sp>
       <p:sp>
         <p:nvSpPr>
-          <p:cNvPr id="16" name="Rectangle 15"/>
+          <p:cNvPr id="18" name="Rectangle 17"/>
           <p:cNvSpPr/>
           <p:nvPr/>
         </p:nvSpPr>
         <p:spPr>
           <a:xfrm>
-            <a:off x="3319272" y="1664208"/>
-            <a:ext cx="2670048" cy="36576"/>
+            <a:off x="3246120" y="1627632"/>
+            <a:ext cx="2724912" cy="36576"/>
           </a:xfrm>
           <a:prstGeom prst="rect">
             <a:avLst/>
@@ -18280,14 +18366,91 @@
       </p:sp>
       <p:sp>
         <p:nvSpPr>
-          <p:cNvPr id="17" name="TextBox 16"/>
-          <p:cNvSpPr txBox="1"/>
-          <p:nvPr/>
-        </p:nvSpPr>
-        <p:spPr>
-          <a:xfrm>
-            <a:off x="3502152" y="1828800"/>
-            <a:ext cx="530352" cy="502920"/>
+          <p:cNvPr id="19" name="Rectangle 18"/>
+          <p:cNvSpPr/>
+          <p:nvPr/>
+        </p:nvSpPr>
+        <p:spPr>
+          <a:xfrm>
+            <a:off x="5495544" y="1719072"/>
+            <a:ext cx="347472" cy="256032"/>
+          </a:xfrm>
+          <a:prstGeom prst="rect">
+            <a:avLst/>
+          </a:prstGeom>
+          <a:solidFill>
+            <a:srgbClr val="1C2E2E"/>
+          </a:solidFill>
+          <a:ln>
+            <a:noFill/>
+          </a:ln>
+        </p:spPr>
+        <p:style>
+          <a:lnRef idx="1">
+            <a:schemeClr val="accent1"/>
+          </a:lnRef>
+          <a:fillRef idx="3">
+            <a:schemeClr val="accent1"/>
+          </a:fillRef>
+          <a:effectRef idx="2">
+            <a:schemeClr val="accent1"/>
+          </a:effectRef>
+          <a:fontRef idx="minor">
+            <a:schemeClr val="lt1"/>
+          </a:fontRef>
+        </p:style>
+        <p:txBody>
+          <a:bodyPr rtlCol="0" anchor="ctr"/>
+          <a:lstStyle/>
+          <a:p>
+            <a:pPr algn="ctr"/>
+          </a:p>
+        </p:txBody>
+      </p:sp>
+      <p:sp>
+        <p:nvSpPr>
+          <p:cNvPr id="20" name="TextBox 19"/>
+          <p:cNvSpPr txBox="1"/>
+          <p:nvPr/>
+        </p:nvSpPr>
+        <p:spPr>
+          <a:xfrm>
+            <a:off x="5495544" y="1719072"/>
+            <a:ext cx="347472" cy="256032"/>
+          </a:xfrm>
+          <a:prstGeom prst="rect">
+            <a:avLst/>
+          </a:prstGeom>
+          <a:noFill/>
+        </p:spPr>
+        <p:txBody>
+          <a:bodyPr wrap="square">
+            <a:spAutoFit/>
+          </a:bodyPr>
+          <a:lstStyle/>
+          <a:p>
+            <a:pPr algn="ctr"/>
+            <a:r>
+              <a:rPr sz="800" b="1" i="0">
+                <a:solidFill>
+                  <a:srgbClr val="3AAEAE"/>
+                </a:solidFill>
+              </a:rPr>
+              <a:t>02</a:t>
+            </a:r>
+          </a:p>
+        </p:txBody>
+      </p:sp>
+      <p:sp>
+        <p:nvSpPr>
+          <p:cNvPr id="21" name="TextBox 20"/>
+          <p:cNvSpPr txBox="1"/>
+          <p:nvPr/>
+        </p:nvSpPr>
+        <p:spPr>
+          <a:xfrm>
+            <a:off x="3383280" y="1719072"/>
+            <a:ext cx="502920" cy="475488"/>
           </a:xfrm>
           <a:prstGeom prst="rect">
             <a:avLst/>
@@ -18314,63 +18477,29 @@
       </p:sp>
       <p:sp>
         <p:nvSpPr>
-          <p:cNvPr id="18" name="TextBox 17"/>
-          <p:cNvSpPr txBox="1"/>
-          <p:nvPr/>
-        </p:nvSpPr>
-        <p:spPr>
-          <a:xfrm>
-            <a:off x="5349240" y="1847088"/>
-            <a:ext cx="502920" cy="347472"/>
-          </a:xfrm>
-          <a:prstGeom prst="rect">
-            <a:avLst/>
-          </a:prstGeom>
-          <a:noFill/>
-        </p:spPr>
-        <p:txBody>
-          <a:bodyPr wrap="square">
-            <a:spAutoFit/>
-          </a:bodyPr>
-          <a:lstStyle/>
-          <a:p>
-            <a:pPr algn="r"/>
-            <a:r>
-              <a:rPr sz="1800" b="1" i="0">
-                <a:solidFill>
-                  <a:srgbClr val="2B8E8E"/>
-                </a:solidFill>
-              </a:rPr>
-              <a:t>02</a:t>
-            </a:r>
-          </a:p>
-        </p:txBody>
-      </p:sp>
-      <p:sp>
-        <p:nvSpPr>
-          <p:cNvPr id="19" name="TextBox 18"/>
-          <p:cNvSpPr txBox="1"/>
-          <p:nvPr/>
-        </p:nvSpPr>
-        <p:spPr>
-          <a:xfrm>
-            <a:off x="3502152" y="2359152"/>
-            <a:ext cx="2304288" cy="347472"/>
-          </a:xfrm>
-          <a:prstGeom prst="rect">
-            <a:avLst/>
-          </a:prstGeom>
-          <a:noFill/>
-        </p:spPr>
-        <p:txBody>
-          <a:bodyPr wrap="square">
-            <a:spAutoFit/>
-          </a:bodyPr>
-          <a:lstStyle/>
-          <a:p>
-            <a:pPr algn="l"/>
-            <a:r>
-              <a:rPr sz="1200" b="1" i="0">
+          <p:cNvPr id="22" name="TextBox 21"/>
+          <p:cNvSpPr txBox="1"/>
+          <p:nvPr/>
+        </p:nvSpPr>
+        <p:spPr>
+          <a:xfrm>
+            <a:off x="3383280" y="2267712"/>
+            <a:ext cx="2450592" cy="329184"/>
+          </a:xfrm>
+          <a:prstGeom prst="rect">
+            <a:avLst/>
+          </a:prstGeom>
+          <a:noFill/>
+        </p:spPr>
+        <p:txBody>
+          <a:bodyPr wrap="square">
+            <a:spAutoFit/>
+          </a:bodyPr>
+          <a:lstStyle/>
+          <a:p>
+            <a:pPr algn="l"/>
+            <a:r>
+              <a:rPr sz="1150" b="1" i="0">
                 <a:solidFill>
                   <a:srgbClr val="EEF7F7"/>
                 </a:solidFill>
@@ -18382,14 +18511,57 @@
       </p:sp>
       <p:sp>
         <p:nvSpPr>
-          <p:cNvPr id="20" name="TextBox 19"/>
-          <p:cNvSpPr txBox="1"/>
-          <p:nvPr/>
-        </p:nvSpPr>
-        <p:spPr>
-          <a:xfrm>
-            <a:off x="3502152" y="2743200"/>
-            <a:ext cx="2304288" cy="1325880"/>
+          <p:cNvPr id="23" name="Rectangle 22"/>
+          <p:cNvSpPr/>
+          <p:nvPr/>
+        </p:nvSpPr>
+        <p:spPr>
+          <a:xfrm>
+            <a:off x="3383280" y="2633472"/>
+            <a:ext cx="2450592" cy="7315"/>
+          </a:xfrm>
+          <a:prstGeom prst="rect">
+            <a:avLst/>
+          </a:prstGeom>
+          <a:solidFill>
+            <a:srgbClr val="1C2E2E"/>
+          </a:solidFill>
+          <a:ln>
+            <a:noFill/>
+          </a:ln>
+        </p:spPr>
+        <p:style>
+          <a:lnRef idx="1">
+            <a:schemeClr val="accent1"/>
+          </a:lnRef>
+          <a:fillRef idx="3">
+            <a:schemeClr val="accent1"/>
+          </a:fillRef>
+          <a:effectRef idx="2">
+            <a:schemeClr val="accent1"/>
+          </a:effectRef>
+          <a:fontRef idx="minor">
+            <a:schemeClr val="lt1"/>
+          </a:fontRef>
+        </p:style>
+        <p:txBody>
+          <a:bodyPr rtlCol="0" anchor="ctr"/>
+          <a:lstStyle/>
+          <a:p>
+            <a:pPr algn="ctr"/>
+          </a:p>
+        </p:txBody>
+      </p:sp>
+      <p:sp>
+        <p:nvSpPr>
+          <p:cNvPr id="24" name="TextBox 23"/>
+          <p:cNvSpPr txBox="1"/>
+          <p:nvPr/>
+        </p:nvSpPr>
+        <p:spPr>
+          <a:xfrm>
+            <a:off x="3383280" y="2724912"/>
+            <a:ext cx="2450592" cy="1188720"/>
           </a:xfrm>
           <a:prstGeom prst="rect">
             <a:avLst/>
@@ -18409,21 +18581,21 @@
                   <a:srgbClr val="9ABFBF"/>
                 </a:solidFill>
               </a:rPr>
-              <a:t>Is it mobile-friendly? Fast? Does it convert — or is it a liability?</a:t>
-            </a:r>
-          </a:p>
-        </p:txBody>
-      </p:sp>
-      <p:sp>
-        <p:nvSpPr>
-          <p:cNvPr id="21" name="Rectangle 20"/>
+              <a:t>Is it mobile-friendly? Fast? Does it actually convert — or is it a liability?</a:t>
+            </a:r>
+          </a:p>
+        </p:txBody>
+      </p:sp>
+      <p:sp>
+        <p:nvSpPr>
+          <p:cNvPr id="25" name="Rectangle 24"/>
           <p:cNvSpPr/>
           <p:nvPr/>
         </p:nvSpPr>
         <p:spPr>
           <a:xfrm>
-            <a:off x="6227064" y="1664208"/>
-            <a:ext cx="2670048" cy="2514600"/>
+            <a:off x="6080760" y="1627632"/>
+            <a:ext cx="2724912" cy="2377440"/>
           </a:xfrm>
           <a:prstGeom prst="rect">
             <a:avLst/>
@@ -18461,14 +18633,14 @@
       </p:sp>
       <p:sp>
         <p:nvSpPr>
-          <p:cNvPr id="22" name="Rectangle 21"/>
+          <p:cNvPr id="26" name="Rectangle 25"/>
           <p:cNvSpPr/>
           <p:nvPr/>
         </p:nvSpPr>
         <p:spPr>
           <a:xfrm>
-            <a:off x="6227064" y="1664208"/>
-            <a:ext cx="2670048" cy="36576"/>
+            <a:off x="6080760" y="1627632"/>
+            <a:ext cx="2724912" cy="36576"/>
           </a:xfrm>
           <a:prstGeom prst="rect">
             <a:avLst/>
@@ -18504,150 +18676,236 @@
       </p:sp>
       <p:sp>
         <p:nvSpPr>
-          <p:cNvPr id="23" name="TextBox 22"/>
-          <p:cNvSpPr txBox="1"/>
-          <p:nvPr/>
-        </p:nvSpPr>
-        <p:spPr>
-          <a:xfrm>
-            <a:off x="6409944" y="1828800"/>
-            <a:ext cx="530352" cy="502920"/>
-          </a:xfrm>
-          <a:prstGeom prst="rect">
-            <a:avLst/>
-          </a:prstGeom>
-          <a:noFill/>
-        </p:spPr>
-        <p:txBody>
-          <a:bodyPr wrap="square">
-            <a:spAutoFit/>
-          </a:bodyPr>
-          <a:lstStyle/>
-          <a:p>
-            <a:pPr algn="l"/>
-            <a:r>
-              <a:rPr sz="2400" b="0" i="0">
-                <a:solidFill>
-                  <a:srgbClr val="EEF7F7"/>
-                </a:solidFill>
-              </a:rPr>
-              <a:t>⭐</a:t>
-            </a:r>
-          </a:p>
-        </p:txBody>
-      </p:sp>
-      <p:sp>
-        <p:nvSpPr>
-          <p:cNvPr id="24" name="TextBox 23"/>
-          <p:cNvSpPr txBox="1"/>
-          <p:nvPr/>
-        </p:nvSpPr>
-        <p:spPr>
-          <a:xfrm>
-            <a:off x="8257032" y="1847088"/>
-            <a:ext cx="502920" cy="347472"/>
-          </a:xfrm>
-          <a:prstGeom prst="rect">
-            <a:avLst/>
-          </a:prstGeom>
-          <a:noFill/>
-        </p:spPr>
-        <p:txBody>
-          <a:bodyPr wrap="square">
-            <a:spAutoFit/>
-          </a:bodyPr>
-          <a:lstStyle/>
-          <a:p>
-            <a:pPr algn="r"/>
-            <a:r>
-              <a:rPr sz="1800" b="1" i="0">
-                <a:solidFill>
-                  <a:srgbClr val="2B8E8E"/>
-                </a:solidFill>
-              </a:rPr>
-              <a:t>03</a:t>
-            </a:r>
-          </a:p>
-        </p:txBody>
-      </p:sp>
-      <p:sp>
-        <p:nvSpPr>
-          <p:cNvPr id="25" name="TextBox 24"/>
-          <p:cNvSpPr txBox="1"/>
-          <p:nvPr/>
-        </p:nvSpPr>
-        <p:spPr>
-          <a:xfrm>
-            <a:off x="6409944" y="2359152"/>
-            <a:ext cx="2304288" cy="347472"/>
-          </a:xfrm>
-          <a:prstGeom prst="rect">
-            <a:avLst/>
-          </a:prstGeom>
-          <a:noFill/>
-        </p:spPr>
-        <p:txBody>
-          <a:bodyPr wrap="square">
-            <a:spAutoFit/>
-          </a:bodyPr>
-          <a:lstStyle/>
-          <a:p>
-            <a:pPr algn="l"/>
-            <a:r>
-              <a:rPr sz="1200" b="1" i="0">
-                <a:solidFill>
-                  <a:srgbClr val="EEF7F7"/>
-                </a:solidFill>
-              </a:rPr>
-              <a:t>Google Maps Rating</a:t>
-            </a:r>
-          </a:p>
-        </p:txBody>
-      </p:sp>
-      <p:sp>
-        <p:nvSpPr>
-          <p:cNvPr id="26" name="TextBox 25"/>
-          <p:cNvSpPr txBox="1"/>
-          <p:nvPr/>
-        </p:nvSpPr>
-        <p:spPr>
-          <a:xfrm>
-            <a:off x="6409944" y="2743200"/>
-            <a:ext cx="2304288" cy="1325880"/>
-          </a:xfrm>
-          <a:prstGeom prst="rect">
-            <a:avLst/>
-          </a:prstGeom>
-          <a:noFill/>
-        </p:spPr>
-        <p:txBody>
-          <a:bodyPr wrap="square">
-            <a:spAutoFit/>
-          </a:bodyPr>
-          <a:lstStyle/>
-          <a:p>
-            <a:pPr algn="l"/>
-            <a:r>
-              <a:rPr sz="900" b="0" i="0">
-                <a:solidFill>
-                  <a:srgbClr val="9ABFBF"/>
-                </a:solidFill>
-              </a:rPr>
-              <a:t>Low score = reputation problem. No reviews = visibility problem. You solve both.</a:t>
-            </a:r>
-          </a:p>
-        </p:txBody>
-      </p:sp>
-      <p:sp>
-        <p:nvSpPr>
           <p:cNvPr id="27" name="Rectangle 26"/>
           <p:cNvSpPr/>
           <p:nvPr/>
         </p:nvSpPr>
         <p:spPr>
           <a:xfrm>
-            <a:off x="9134856" y="1664208"/>
-            <a:ext cx="2670048" cy="2514600"/>
+            <a:off x="8330184" y="1719072"/>
+            <a:ext cx="347472" cy="256032"/>
+          </a:xfrm>
+          <a:prstGeom prst="rect">
+            <a:avLst/>
+          </a:prstGeom>
+          <a:solidFill>
+            <a:srgbClr val="1C2E2E"/>
+          </a:solidFill>
+          <a:ln>
+            <a:noFill/>
+          </a:ln>
+        </p:spPr>
+        <p:style>
+          <a:lnRef idx="1">
+            <a:schemeClr val="accent1"/>
+          </a:lnRef>
+          <a:fillRef idx="3">
+            <a:schemeClr val="accent1"/>
+          </a:fillRef>
+          <a:effectRef idx="2">
+            <a:schemeClr val="accent1"/>
+          </a:effectRef>
+          <a:fontRef idx="minor">
+            <a:schemeClr val="lt1"/>
+          </a:fontRef>
+        </p:style>
+        <p:txBody>
+          <a:bodyPr rtlCol="0" anchor="ctr"/>
+          <a:lstStyle/>
+          <a:p>
+            <a:pPr algn="ctr"/>
+          </a:p>
+        </p:txBody>
+      </p:sp>
+      <p:sp>
+        <p:nvSpPr>
+          <p:cNvPr id="28" name="TextBox 27"/>
+          <p:cNvSpPr txBox="1"/>
+          <p:nvPr/>
+        </p:nvSpPr>
+        <p:spPr>
+          <a:xfrm>
+            <a:off x="8330184" y="1719072"/>
+            <a:ext cx="347472" cy="256032"/>
+          </a:xfrm>
+          <a:prstGeom prst="rect">
+            <a:avLst/>
+          </a:prstGeom>
+          <a:noFill/>
+        </p:spPr>
+        <p:txBody>
+          <a:bodyPr wrap="square">
+            <a:spAutoFit/>
+          </a:bodyPr>
+          <a:lstStyle/>
+          <a:p>
+            <a:pPr algn="ctr"/>
+            <a:r>
+              <a:rPr sz="800" b="1" i="0">
+                <a:solidFill>
+                  <a:srgbClr val="3AAEAE"/>
+                </a:solidFill>
+              </a:rPr>
+              <a:t>03</a:t>
+            </a:r>
+          </a:p>
+        </p:txBody>
+      </p:sp>
+      <p:sp>
+        <p:nvSpPr>
+          <p:cNvPr id="29" name="TextBox 28"/>
+          <p:cNvSpPr txBox="1"/>
+          <p:nvPr/>
+        </p:nvSpPr>
+        <p:spPr>
+          <a:xfrm>
+            <a:off x="6217920" y="1719072"/>
+            <a:ext cx="502920" cy="475488"/>
+          </a:xfrm>
+          <a:prstGeom prst="rect">
+            <a:avLst/>
+          </a:prstGeom>
+          <a:noFill/>
+        </p:spPr>
+        <p:txBody>
+          <a:bodyPr wrap="square">
+            <a:spAutoFit/>
+          </a:bodyPr>
+          <a:lstStyle/>
+          <a:p>
+            <a:pPr algn="l"/>
+            <a:r>
+              <a:rPr sz="2400" b="0" i="0">
+                <a:solidFill>
+                  <a:srgbClr val="EEF7F7"/>
+                </a:solidFill>
+              </a:rPr>
+              <a:t>⭐</a:t>
+            </a:r>
+          </a:p>
+        </p:txBody>
+      </p:sp>
+      <p:sp>
+        <p:nvSpPr>
+          <p:cNvPr id="30" name="TextBox 29"/>
+          <p:cNvSpPr txBox="1"/>
+          <p:nvPr/>
+        </p:nvSpPr>
+        <p:spPr>
+          <a:xfrm>
+            <a:off x="6217920" y="2267712"/>
+            <a:ext cx="2450592" cy="329184"/>
+          </a:xfrm>
+          <a:prstGeom prst="rect">
+            <a:avLst/>
+          </a:prstGeom>
+          <a:noFill/>
+        </p:spPr>
+        <p:txBody>
+          <a:bodyPr wrap="square">
+            <a:spAutoFit/>
+          </a:bodyPr>
+          <a:lstStyle/>
+          <a:p>
+            <a:pPr algn="l"/>
+            <a:r>
+              <a:rPr sz="1150" b="1" i="0">
+                <a:solidFill>
+                  <a:srgbClr val="EEF7F7"/>
+                </a:solidFill>
+              </a:rPr>
+              <a:t>Google Maps Rating</a:t>
+            </a:r>
+          </a:p>
+        </p:txBody>
+      </p:sp>
+      <p:sp>
+        <p:nvSpPr>
+          <p:cNvPr id="31" name="Rectangle 30"/>
+          <p:cNvSpPr/>
+          <p:nvPr/>
+        </p:nvSpPr>
+        <p:spPr>
+          <a:xfrm>
+            <a:off x="6217920" y="2633472"/>
+            <a:ext cx="2450592" cy="7315"/>
+          </a:xfrm>
+          <a:prstGeom prst="rect">
+            <a:avLst/>
+          </a:prstGeom>
+          <a:solidFill>
+            <a:srgbClr val="1C2E2E"/>
+          </a:solidFill>
+          <a:ln>
+            <a:noFill/>
+          </a:ln>
+        </p:spPr>
+        <p:style>
+          <a:lnRef idx="1">
+            <a:schemeClr val="accent1"/>
+          </a:lnRef>
+          <a:fillRef idx="3">
+            <a:schemeClr val="accent1"/>
+          </a:fillRef>
+          <a:effectRef idx="2">
+            <a:schemeClr val="accent1"/>
+          </a:effectRef>
+          <a:fontRef idx="minor">
+            <a:schemeClr val="lt1"/>
+          </a:fontRef>
+        </p:style>
+        <p:txBody>
+          <a:bodyPr rtlCol="0" anchor="ctr"/>
+          <a:lstStyle/>
+          <a:p>
+            <a:pPr algn="ctr"/>
+          </a:p>
+        </p:txBody>
+      </p:sp>
+      <p:sp>
+        <p:nvSpPr>
+          <p:cNvPr id="32" name="TextBox 31"/>
+          <p:cNvSpPr txBox="1"/>
+          <p:nvPr/>
+        </p:nvSpPr>
+        <p:spPr>
+          <a:xfrm>
+            <a:off x="6217920" y="2724912"/>
+            <a:ext cx="2450592" cy="1188720"/>
+          </a:xfrm>
+          <a:prstGeom prst="rect">
+            <a:avLst/>
+          </a:prstGeom>
+          <a:noFill/>
+        </p:spPr>
+        <p:txBody>
+          <a:bodyPr wrap="square">
+            <a:spAutoFit/>
+          </a:bodyPr>
+          <a:lstStyle/>
+          <a:p>
+            <a:pPr algn="l"/>
+            <a:r>
+              <a:rPr sz="900" b="0" i="0">
+                <a:solidFill>
+                  <a:srgbClr val="9ABFBF"/>
+                </a:solidFill>
+              </a:rPr>
+              <a:t>Low score = reputation problem. No reviews = visibility problem. You solve both.</a:t>
+            </a:r>
+          </a:p>
+        </p:txBody>
+      </p:sp>
+      <p:sp>
+        <p:nvSpPr>
+          <p:cNvPr id="33" name="Rectangle 32"/>
+          <p:cNvSpPr/>
+          <p:nvPr/>
+        </p:nvSpPr>
+        <p:spPr>
+          <a:xfrm>
+            <a:off x="8915400" y="1627632"/>
+            <a:ext cx="2724912" cy="2377440"/>
           </a:xfrm>
           <a:prstGeom prst="rect">
             <a:avLst/>
@@ -18685,14 +18943,14 @@
       </p:sp>
       <p:sp>
         <p:nvSpPr>
-          <p:cNvPr id="28" name="Rectangle 27"/>
+          <p:cNvPr id="34" name="Rectangle 33"/>
           <p:cNvSpPr/>
           <p:nvPr/>
         </p:nvSpPr>
         <p:spPr>
           <a:xfrm>
-            <a:off x="9134856" y="1664208"/>
-            <a:ext cx="2670048" cy="36576"/>
+            <a:off x="8915400" y="1627632"/>
+            <a:ext cx="2724912" cy="36576"/>
           </a:xfrm>
           <a:prstGeom prst="rect">
             <a:avLst/>
@@ -18728,156 +18986,20 @@
       </p:sp>
       <p:sp>
         <p:nvSpPr>
-          <p:cNvPr id="29" name="TextBox 28"/>
-          <p:cNvSpPr txBox="1"/>
-          <p:nvPr/>
-        </p:nvSpPr>
-        <p:spPr>
-          <a:xfrm>
-            <a:off x="9317736" y="1828800"/>
-            <a:ext cx="530352" cy="502920"/>
-          </a:xfrm>
-          <a:prstGeom prst="rect">
-            <a:avLst/>
-          </a:prstGeom>
-          <a:noFill/>
-        </p:spPr>
-        <p:txBody>
-          <a:bodyPr wrap="square">
-            <a:spAutoFit/>
-          </a:bodyPr>
-          <a:lstStyle/>
-          <a:p>
-            <a:pPr algn="l"/>
-            <a:r>
-              <a:rPr sz="2400" b="0" i="0">
-                <a:solidFill>
-                  <a:srgbClr val="EEF7F7"/>
-                </a:solidFill>
-              </a:rPr>
-              <a:t>⚔️</a:t>
-            </a:r>
-          </a:p>
-        </p:txBody>
-      </p:sp>
-      <p:sp>
-        <p:nvSpPr>
-          <p:cNvPr id="30" name="TextBox 29"/>
-          <p:cNvSpPr txBox="1"/>
-          <p:nvPr/>
-        </p:nvSpPr>
-        <p:spPr>
-          <a:xfrm>
-            <a:off x="11164824" y="1847088"/>
-            <a:ext cx="502920" cy="347472"/>
-          </a:xfrm>
-          <a:prstGeom prst="rect">
-            <a:avLst/>
-          </a:prstGeom>
-          <a:noFill/>
-        </p:spPr>
-        <p:txBody>
-          <a:bodyPr wrap="square">
-            <a:spAutoFit/>
-          </a:bodyPr>
-          <a:lstStyle/>
-          <a:p>
-            <a:pPr algn="r"/>
-            <a:r>
-              <a:rPr sz="1800" b="1" i="0">
-                <a:solidFill>
-                  <a:srgbClr val="2B8E8E"/>
-                </a:solidFill>
-              </a:rPr>
-              <a:t>04</a:t>
-            </a:r>
-          </a:p>
-        </p:txBody>
-      </p:sp>
-      <p:sp>
-        <p:nvSpPr>
-          <p:cNvPr id="31" name="TextBox 30"/>
-          <p:cNvSpPr txBox="1"/>
-          <p:nvPr/>
-        </p:nvSpPr>
-        <p:spPr>
-          <a:xfrm>
-            <a:off x="9317736" y="2359152"/>
-            <a:ext cx="2304288" cy="347472"/>
-          </a:xfrm>
-          <a:prstGeom prst="rect">
-            <a:avLst/>
-          </a:prstGeom>
-          <a:noFill/>
-        </p:spPr>
-        <p:txBody>
-          <a:bodyPr wrap="square">
-            <a:spAutoFit/>
-          </a:bodyPr>
-          <a:lstStyle/>
-          <a:p>
-            <a:pPr algn="l"/>
-            <a:r>
-              <a:rPr sz="1200" b="1" i="0">
-                <a:solidFill>
-                  <a:srgbClr val="EEF7F7"/>
-                </a:solidFill>
-              </a:rPr>
-              <a:t>Competitor Audit</a:t>
-            </a:r>
-          </a:p>
-        </p:txBody>
-      </p:sp>
-      <p:sp>
-        <p:nvSpPr>
-          <p:cNvPr id="32" name="TextBox 31"/>
-          <p:cNvSpPr txBox="1"/>
-          <p:nvPr/>
-        </p:nvSpPr>
-        <p:spPr>
-          <a:xfrm>
-            <a:off x="9317736" y="2743200"/>
-            <a:ext cx="2304288" cy="1325880"/>
-          </a:xfrm>
-          <a:prstGeom prst="rect">
-            <a:avLst/>
-          </a:prstGeom>
-          <a:noFill/>
-        </p:spPr>
-        <p:txBody>
-          <a:bodyPr wrap="square">
-            <a:spAutoFit/>
-          </a:bodyPr>
-          <a:lstStyle/>
-          <a:p>
-            <a:pPr algn="l"/>
-            <a:r>
-              <a:rPr sz="900" b="0" i="0">
-                <a:solidFill>
-                  <a:srgbClr val="9ABFBF"/>
-                </a:solidFill>
-              </a:rPr>
-              <a:t>Find their top 3 local competitors. Check their presence. Use it to create urgency.</a:t>
-            </a:r>
-          </a:p>
-        </p:txBody>
-      </p:sp>
-      <p:sp>
-        <p:nvSpPr>
-          <p:cNvPr id="33" name="Rectangle 32"/>
+          <p:cNvPr id="35" name="Rectangle 34"/>
           <p:cNvSpPr/>
           <p:nvPr/>
         </p:nvSpPr>
         <p:spPr>
           <a:xfrm>
-            <a:off x="411480" y="4315968"/>
-            <a:ext cx="11365992" cy="1115568"/>
-          </a:xfrm>
-          <a:prstGeom prst="rect">
-            <a:avLst/>
-          </a:prstGeom>
-          <a:solidFill>
-            <a:srgbClr val="0F1A1A"/>
+            <a:off x="11164824" y="1719072"/>
+            <a:ext cx="347472" cy="256032"/>
+          </a:xfrm>
+          <a:prstGeom prst="rect">
+            <a:avLst/>
+          </a:prstGeom>
+          <a:solidFill>
+            <a:srgbClr val="1C2E2E"/>
           </a:solidFill>
           <a:ln>
             <a:noFill/>
@@ -18907,20 +19029,122 @@
       </p:sp>
       <p:sp>
         <p:nvSpPr>
-          <p:cNvPr id="34" name="Rectangle 33"/>
+          <p:cNvPr id="36" name="TextBox 35"/>
+          <p:cNvSpPr txBox="1"/>
+          <p:nvPr/>
+        </p:nvSpPr>
+        <p:spPr>
+          <a:xfrm>
+            <a:off x="11164824" y="1719072"/>
+            <a:ext cx="347472" cy="256032"/>
+          </a:xfrm>
+          <a:prstGeom prst="rect">
+            <a:avLst/>
+          </a:prstGeom>
+          <a:noFill/>
+        </p:spPr>
+        <p:txBody>
+          <a:bodyPr wrap="square">
+            <a:spAutoFit/>
+          </a:bodyPr>
+          <a:lstStyle/>
+          <a:p>
+            <a:pPr algn="ctr"/>
+            <a:r>
+              <a:rPr sz="800" b="1" i="0">
+                <a:solidFill>
+                  <a:srgbClr val="3AAEAE"/>
+                </a:solidFill>
+              </a:rPr>
+              <a:t>04</a:t>
+            </a:r>
+          </a:p>
+        </p:txBody>
+      </p:sp>
+      <p:sp>
+        <p:nvSpPr>
+          <p:cNvPr id="37" name="TextBox 36"/>
+          <p:cNvSpPr txBox="1"/>
+          <p:nvPr/>
+        </p:nvSpPr>
+        <p:spPr>
+          <a:xfrm>
+            <a:off x="9052560" y="1719072"/>
+            <a:ext cx="502920" cy="475488"/>
+          </a:xfrm>
+          <a:prstGeom prst="rect">
+            <a:avLst/>
+          </a:prstGeom>
+          <a:noFill/>
+        </p:spPr>
+        <p:txBody>
+          <a:bodyPr wrap="square">
+            <a:spAutoFit/>
+          </a:bodyPr>
+          <a:lstStyle/>
+          <a:p>
+            <a:pPr algn="l"/>
+            <a:r>
+              <a:rPr sz="2400" b="0" i="0">
+                <a:solidFill>
+                  <a:srgbClr val="EEF7F7"/>
+                </a:solidFill>
+              </a:rPr>
+              <a:t>⚔️</a:t>
+            </a:r>
+          </a:p>
+        </p:txBody>
+      </p:sp>
+      <p:sp>
+        <p:nvSpPr>
+          <p:cNvPr id="38" name="TextBox 37"/>
+          <p:cNvSpPr txBox="1"/>
+          <p:nvPr/>
+        </p:nvSpPr>
+        <p:spPr>
+          <a:xfrm>
+            <a:off x="9052560" y="2267712"/>
+            <a:ext cx="2450592" cy="329184"/>
+          </a:xfrm>
+          <a:prstGeom prst="rect">
+            <a:avLst/>
+          </a:prstGeom>
+          <a:noFill/>
+        </p:spPr>
+        <p:txBody>
+          <a:bodyPr wrap="square">
+            <a:spAutoFit/>
+          </a:bodyPr>
+          <a:lstStyle/>
+          <a:p>
+            <a:pPr algn="l"/>
+            <a:r>
+              <a:rPr sz="1150" b="1" i="0">
+                <a:solidFill>
+                  <a:srgbClr val="EEF7F7"/>
+                </a:solidFill>
+              </a:rPr>
+              <a:t>Competitor Audit</a:t>
+            </a:r>
+          </a:p>
+        </p:txBody>
+      </p:sp>
+      <p:sp>
+        <p:nvSpPr>
+          <p:cNvPr id="39" name="Rectangle 38"/>
           <p:cNvSpPr/>
           <p:nvPr/>
         </p:nvSpPr>
         <p:spPr>
           <a:xfrm>
-            <a:off x="411480" y="4315968"/>
-            <a:ext cx="45720" cy="1115568"/>
-          </a:xfrm>
-          <a:prstGeom prst="rect">
-            <a:avLst/>
-          </a:prstGeom>
-          <a:solidFill>
-            <a:srgbClr val="2B8E8E"/>
+            <a:off x="9052560" y="2633472"/>
+            <a:ext cx="2450592" cy="7315"/>
+          </a:xfrm>
+          <a:prstGeom prst="rect">
+            <a:avLst/>
+          </a:prstGeom>
+          <a:solidFill>
+            <a:srgbClr val="1C2E2E"/>
           </a:solidFill>
           <a:ln>
             <a:noFill/>
@@ -18950,88 +19174,54 @@
       </p:sp>
       <p:sp>
         <p:nvSpPr>
-          <p:cNvPr id="35" name="TextBox 34"/>
-          <p:cNvSpPr txBox="1"/>
-          <p:nvPr/>
-        </p:nvSpPr>
-        <p:spPr>
-          <a:xfrm>
-            <a:off x="566928" y="4389120"/>
-            <a:ext cx="2743200" cy="201168"/>
-          </a:xfrm>
-          <a:prstGeom prst="rect">
-            <a:avLst/>
-          </a:prstGeom>
-          <a:noFill/>
-        </p:spPr>
-        <p:txBody>
-          <a:bodyPr wrap="square">
-            <a:spAutoFit/>
-          </a:bodyPr>
-          <a:lstStyle/>
-          <a:p>
-            <a:pPr algn="l"/>
-            <a:r>
-              <a:rPr sz="700" b="1" i="0">
-                <a:solidFill>
-                  <a:srgbClr val="3AAEAE"/>
-                </a:solidFill>
-              </a:rPr>
-              <a:t>OPENING LINE</a:t>
-            </a:r>
-          </a:p>
-        </p:txBody>
-      </p:sp>
-      <p:sp>
-        <p:nvSpPr>
-          <p:cNvPr id="36" name="TextBox 35"/>
-          <p:cNvSpPr txBox="1"/>
-          <p:nvPr/>
-        </p:nvSpPr>
-        <p:spPr>
-          <a:xfrm>
-            <a:off x="566928" y="4608576"/>
-            <a:ext cx="10972800" cy="749808"/>
-          </a:xfrm>
-          <a:prstGeom prst="rect">
-            <a:avLst/>
-          </a:prstGeom>
-          <a:noFill/>
-        </p:spPr>
-        <p:txBody>
-          <a:bodyPr wrap="square">
-            <a:spAutoFit/>
-          </a:bodyPr>
-          <a:lstStyle/>
-          <a:p>
-            <a:pPr algn="l"/>
-            <a:r>
-              <a:rPr sz="1000" b="0" i="1">
+          <p:cNvPr id="40" name="TextBox 39"/>
+          <p:cNvSpPr txBox="1"/>
+          <p:nvPr/>
+        </p:nvSpPr>
+        <p:spPr>
+          <a:xfrm>
+            <a:off x="9052560" y="2724912"/>
+            <a:ext cx="2450592" cy="1188720"/>
+          </a:xfrm>
+          <a:prstGeom prst="rect">
+            <a:avLst/>
+          </a:prstGeom>
+          <a:noFill/>
+        </p:spPr>
+        <p:txBody>
+          <a:bodyPr wrap="square">
+            <a:spAutoFit/>
+          </a:bodyPr>
+          <a:lstStyle/>
+          <a:p>
+            <a:pPr algn="l"/>
+            <a:r>
+              <a:rPr sz="900" b="0" i="0">
                 <a:solidFill>
                   <a:srgbClr val="9ABFBF"/>
                 </a:solidFill>
               </a:rPr>
-              <a:t>"I had a look at your business before coming in today. I noticed a few things I wanted to talk about — but first, tell me how business has been. Are you getting as many new customers as you want?"</a:t>
-            </a:r>
-          </a:p>
-        </p:txBody>
-      </p:sp>
-      <p:sp>
-        <p:nvSpPr>
-          <p:cNvPr id="37" name="Rectangle 36"/>
+              <a:t>Find their top 3 local competitors. Check their online presence. You'll use this to create urgency.</a:t>
+            </a:r>
+          </a:p>
+        </p:txBody>
+      </p:sp>
+      <p:sp>
+        <p:nvSpPr>
+          <p:cNvPr id="41" name="Rectangle 40"/>
           <p:cNvSpPr/>
           <p:nvPr/>
         </p:nvSpPr>
         <p:spPr>
           <a:xfrm>
-            <a:off x="411480" y="5541264"/>
-            <a:ext cx="11365992" cy="749808"/>
-          </a:xfrm>
-          <a:prstGeom prst="rect">
-            <a:avLst/>
-          </a:prstGeom>
-          <a:solidFill>
-            <a:srgbClr val="220808"/>
+            <a:off x="411480" y="4133087"/>
+            <a:ext cx="11365992" cy="1005840"/>
+          </a:xfrm>
+          <a:prstGeom prst="rect">
+            <a:avLst/>
+          </a:prstGeom>
+          <a:solidFill>
+            <a:srgbClr val="0F1A1A"/>
           </a:solidFill>
           <a:ln>
             <a:noFill/>
@@ -19061,20 +19251,20 @@
       </p:sp>
       <p:sp>
         <p:nvSpPr>
-          <p:cNvPr id="38" name="Rectangle 37"/>
+          <p:cNvPr id="42" name="Rectangle 41"/>
           <p:cNvSpPr/>
           <p:nvPr/>
         </p:nvSpPr>
         <p:spPr>
           <a:xfrm>
-            <a:off x="411480" y="5541264"/>
-            <a:ext cx="45720" cy="749808"/>
-          </a:xfrm>
-          <a:prstGeom prst="rect">
-            <a:avLst/>
-          </a:prstGeom>
-          <a:solidFill>
-            <a:srgbClr val="EF4444"/>
+            <a:off x="411480" y="4133087"/>
+            <a:ext cx="45720" cy="1005840"/>
+          </a:xfrm>
+          <a:prstGeom prst="rect">
+            <a:avLst/>
+          </a:prstGeom>
+          <a:solidFill>
+            <a:srgbClr val="2B8E8E"/>
           </a:solidFill>
           <a:ln>
             <a:noFill/>
@@ -19104,14 +19294,168 @@
       </p:sp>
       <p:sp>
         <p:nvSpPr>
-          <p:cNvPr id="39" name="TextBox 38"/>
-          <p:cNvSpPr txBox="1"/>
-          <p:nvPr/>
-        </p:nvSpPr>
-        <p:spPr>
-          <a:xfrm>
-            <a:off x="566928" y="5687568"/>
-            <a:ext cx="10972800" cy="475488"/>
+          <p:cNvPr id="43" name="TextBox 42"/>
+          <p:cNvSpPr txBox="1"/>
+          <p:nvPr/>
+        </p:nvSpPr>
+        <p:spPr>
+          <a:xfrm>
+            <a:off x="566928" y="4206240"/>
+            <a:ext cx="2743200" cy="201168"/>
+          </a:xfrm>
+          <a:prstGeom prst="rect">
+            <a:avLst/>
+          </a:prstGeom>
+          <a:noFill/>
+        </p:spPr>
+        <p:txBody>
+          <a:bodyPr wrap="square">
+            <a:spAutoFit/>
+          </a:bodyPr>
+          <a:lstStyle/>
+          <a:p>
+            <a:pPr algn="l"/>
+            <a:r>
+              <a:rPr sz="700" b="1" i="0">
+                <a:solidFill>
+                  <a:srgbClr val="3AAEAE"/>
+                </a:solidFill>
+              </a:rPr>
+              <a:t>OPENING LINE</a:t>
+            </a:r>
+          </a:p>
+        </p:txBody>
+      </p:sp>
+      <p:sp>
+        <p:nvSpPr>
+          <p:cNvPr id="44" name="TextBox 43"/>
+          <p:cNvSpPr txBox="1"/>
+          <p:nvPr/>
+        </p:nvSpPr>
+        <p:spPr>
+          <a:xfrm>
+            <a:off x="566928" y="4416552"/>
+            <a:ext cx="10972800" cy="658368"/>
+          </a:xfrm>
+          <a:prstGeom prst="rect">
+            <a:avLst/>
+          </a:prstGeom>
+          <a:noFill/>
+        </p:spPr>
+        <p:txBody>
+          <a:bodyPr wrap="square">
+            <a:spAutoFit/>
+          </a:bodyPr>
+          <a:lstStyle/>
+          <a:p>
+            <a:pPr algn="l"/>
+            <a:r>
+              <a:rPr sz="1000" b="0" i="1">
+                <a:solidFill>
+                  <a:srgbClr val="9ABFBF"/>
+                </a:solidFill>
+              </a:rPr>
+              <a:t>"I had a look at your business before coming in today. I noticed a few things I wanted to talk about — but first, tell me how business has been. Are you getting as many new customers as you want?"</a:t>
+            </a:r>
+          </a:p>
+        </p:txBody>
+      </p:sp>
+      <p:sp>
+        <p:nvSpPr>
+          <p:cNvPr id="45" name="Rectangle 44"/>
+          <p:cNvSpPr/>
+          <p:nvPr/>
+        </p:nvSpPr>
+        <p:spPr>
+          <a:xfrm>
+            <a:off x="411480" y="5266944"/>
+            <a:ext cx="11365992" cy="676656"/>
+          </a:xfrm>
+          <a:prstGeom prst="rect">
+            <a:avLst/>
+          </a:prstGeom>
+          <a:solidFill>
+            <a:srgbClr val="220808"/>
+          </a:solidFill>
+          <a:ln>
+            <a:noFill/>
+          </a:ln>
+        </p:spPr>
+        <p:style>
+          <a:lnRef idx="1">
+            <a:schemeClr val="accent1"/>
+          </a:lnRef>
+          <a:fillRef idx="3">
+            <a:schemeClr val="accent1"/>
+          </a:fillRef>
+          <a:effectRef idx="2">
+            <a:schemeClr val="accent1"/>
+          </a:effectRef>
+          <a:fontRef idx="minor">
+            <a:schemeClr val="lt1"/>
+          </a:fontRef>
+        </p:style>
+        <p:txBody>
+          <a:bodyPr rtlCol="0" anchor="ctr"/>
+          <a:lstStyle/>
+          <a:p>
+            <a:pPr algn="ctr"/>
+          </a:p>
+        </p:txBody>
+      </p:sp>
+      <p:sp>
+        <p:nvSpPr>
+          <p:cNvPr id="46" name="Rectangle 45"/>
+          <p:cNvSpPr/>
+          <p:nvPr/>
+        </p:nvSpPr>
+        <p:spPr>
+          <a:xfrm>
+            <a:off x="411480" y="5266944"/>
+            <a:ext cx="45720" cy="676656"/>
+          </a:xfrm>
+          <a:prstGeom prst="rect">
+            <a:avLst/>
+          </a:prstGeom>
+          <a:solidFill>
+            <a:srgbClr val="EF4444"/>
+          </a:solidFill>
+          <a:ln>
+            <a:noFill/>
+          </a:ln>
+        </p:spPr>
+        <p:style>
+          <a:lnRef idx="1">
+            <a:schemeClr val="accent1"/>
+          </a:lnRef>
+          <a:fillRef idx="3">
+            <a:schemeClr val="accent1"/>
+          </a:fillRef>
+          <a:effectRef idx="2">
+            <a:schemeClr val="accent1"/>
+          </a:effectRef>
+          <a:fontRef idx="minor">
+            <a:schemeClr val="lt1"/>
+          </a:fontRef>
+        </p:style>
+        <p:txBody>
+          <a:bodyPr rtlCol="0" anchor="ctr"/>
+          <a:lstStyle/>
+          <a:p>
+            <a:pPr algn="ctr"/>
+          </a:p>
+        </p:txBody>
+      </p:sp>
+      <p:sp>
+        <p:nvSpPr>
+          <p:cNvPr id="47" name="TextBox 46"/>
+          <p:cNvSpPr txBox="1"/>
+          <p:nvPr/>
+        </p:nvSpPr>
+        <p:spPr>
+          <a:xfrm>
+            <a:off x="566928" y="5413248"/>
+            <a:ext cx="10972800" cy="438912"/>
           </a:xfrm>
           <a:prstGeom prst="rect">
             <a:avLst/>

</xml_diff>